<commit_message>
Correct submission participant and public access documentation
</commit_message>
<xml_diff>
--- a/docs/release/2026-10-05/Reclama_Hackathon_6_slides_v6_EN.pptx
+++ b/docs/release/2026-10-05/Reclama_Hackathon_6_slides_v6_EN.pptx
@@ -2,18 +2,18 @@
 <file path=ppt/presentation.xml><?xml version="1.0" encoding="utf-8"?>
 <p:presentation xmlns:p="http://schemas.openxmlformats.org/presentationml/2006/main">
   <p:sldMasterIdLst>
-    <p:sldMasterId xmlns:r="http://schemas.openxmlformats.org/officeDocument/2006/relationships" id="2147483648" r:id="R23a3a697432344df"/>
+    <p:sldMasterId xmlns:r="http://schemas.openxmlformats.org/officeDocument/2006/relationships" id="2147483648" r:id="Rfce19aace7294e14"/>
   </p:sldMasterIdLst>
   <p:notesMasterIdLst>
-    <p:notesMasterId xmlns:r="http://schemas.openxmlformats.org/officeDocument/2006/relationships" r:id="R5e61957d9ff5424a"/>
+    <p:notesMasterId xmlns:r="http://schemas.openxmlformats.org/officeDocument/2006/relationships" r:id="Ra0be8f48bd4c455a"/>
   </p:notesMasterIdLst>
   <p:sldIdLst>
-    <p:sldId xmlns:r="http://schemas.openxmlformats.org/officeDocument/2006/relationships" id="256" r:id="Ra3011baccbed4cb9"/>
-    <p:sldId xmlns:r="http://schemas.openxmlformats.org/officeDocument/2006/relationships" id="257" r:id="Rc9f479f8380a40a6"/>
-    <p:sldId xmlns:r="http://schemas.openxmlformats.org/officeDocument/2006/relationships" id="258" r:id="R500690c608974011"/>
-    <p:sldId xmlns:r="http://schemas.openxmlformats.org/officeDocument/2006/relationships" id="259" r:id="R0ed79b7d125c414d"/>
-    <p:sldId xmlns:r="http://schemas.openxmlformats.org/officeDocument/2006/relationships" id="260" r:id="Rd73cc2e0f19c446a"/>
-    <p:sldId xmlns:r="http://schemas.openxmlformats.org/officeDocument/2006/relationships" id="261" r:id="R539e1f929dcc4f10"/>
+    <p:sldId xmlns:r="http://schemas.openxmlformats.org/officeDocument/2006/relationships" id="256" r:id="Rde71a5f8849747d8"/>
+    <p:sldId xmlns:r="http://schemas.openxmlformats.org/officeDocument/2006/relationships" id="257" r:id="Rc0770dd780fc4952"/>
+    <p:sldId xmlns:r="http://schemas.openxmlformats.org/officeDocument/2006/relationships" id="258" r:id="R11d48c06008c4929"/>
+    <p:sldId xmlns:r="http://schemas.openxmlformats.org/officeDocument/2006/relationships" id="259" r:id="Rece3f6b8b5e64bc3"/>
+    <p:sldId xmlns:r="http://schemas.openxmlformats.org/officeDocument/2006/relationships" id="260" r:id="Rf907e9748afd42d5"/>
+    <p:sldId xmlns:r="http://schemas.openxmlformats.org/officeDocument/2006/relationships" id="261" r:id="Rd343e9e1575c4c9c"/>
   </p:sldIdLst>
   <p:sldSz cx="12192000" cy="6858000"/>
   <p:notesSz cx="6858000" cy="9144000"/>
@@ -807,7 +807,7 @@
           <a:lstStyle xmlns:a="http://schemas.openxmlformats.org/drawingml/2006/main"/>
           <a:p xmlns:a="http://schemas.openxmlformats.org/drawingml/2006/main">
             <a:r>
-              <a:t>October 5 private release review. Existing demo: https://reclama-factored-2026.villafortech.chatgpt.site . Private repo: https://github.com/VillaforTech/factored-hackathon-2026-reclama . Draft PR #2 targets codex/reclama. Remote head fa53b3578a2ea33c3037a5c4620832d3d3519a27 has successful CI: https://github.com/VillaforTech/factored-hackathon-2026-reclama/actions/runs/36997154601 . Later local English-guide/release edits are neither deployed nor covered by that CI. Existing deployment source: 3ae216e005b9625a9bc68e4bbf082d86dec7e53b. October 4 policy: custom access for owner and one external viewer. Anonymous-denial checks passed. Normal real-account login, reload and two-account isolation remain unverified. No supported authenticated browser is connected here; that does not prove an identity-provider failure.</a:t>
+              <a:t>Current access update, October 6, 2026 (after the recorded submission deadline). Repository and demo entry point are public with explicit owner approval. Demo: https://reclama-factored-2026.villafortech.chatgpt.site . Repository: https://github.com/VillaforTech/factored-hackathon-2026-reclama . PR #2 merged; live version 7 was built from 52a7ed063f103d812f36225ee15e17664ca029a1. CI for that exact commit passed: https://github.com/VillaforTech/factored-hackathon-2026-reclama/actions/runs/37416039359 . Anonymous HTTP checks returned 200 for the repository, demo landing page and English guide, and 401 SIGN_IN_REQUIRED for the bootstrap API. The case workflow requires normal ChatGPT sign-in. A separate anonymous HTTP sign-in request returned 403; this does not establish what happens in a normal authenticated browser or prove an identity-provider outage. Normal hosted login, reload persistence and isolation between two real accounts remain unverified. No account, invitation or permission bypass was created by these checks.</a:t>
             </a:r>
           </a:p>
           <a:p xmlns:a="http://schemas.openxmlformats.org/drawingml/2006/main">
@@ -817,7 +817,7 @@
           </a:p>
           <a:p xmlns:a="http://schemas.openxmlformats.org/drawingml/2006/main">
             <a:r>
-              <a:t>Official hub requires public repository, working deployed link, 4–6 slides and video at most three minutes: https://www.factored.ai/careers/ai-data-hackathon . English and no face required: https://factored-hackathon.slack.com/archives/C0BUZCY0TUY/p1791153414484629 . Public demo preferred, judges randomly assigned and may contact submitter if access fails: https://factored-hackathon.slack.com/archives/C0BU54YAKMG/p1791153383839789 . This is not an explicit anonymous-access mandate. Publication, invitations, integration, push, deployment and submission still need approval. User will record English demo; no new video produced. Recorded deadline October 5, 23:59 UTC−5: https://factored-hackathon.slack.com/archives/C0BU54YAKMG/p1790614675075619 . No submission receipt. Human language review and real-account A/B tests are internal recommendations, not additional official clauses.</a:t>
+              <a:t>Official hub requires a public repository, working deployed link, 4–6 slides and video at most three minutes: https://www.factored.ai/careers/ai-data-hackathon . English and no face required: https://factored-hackathon.slack.com/archives/C0BUZCY0TUY/p1791153414484629 . Public demo preferred; judges may contact the submitter about access failures: https://factored-hackathon.slack.com/archives/C0BU54YAKMG/p1791153383839789 . This is not an explicit anonymous-workflow mandate. Recorded deadline: October 5, 23:59 UTC−5, https://factored-hackathon.slack.com/archives/C0BU54YAKMG/p1790614675075619 . Deployment and publication are not evidence of timely organizer submission. Human language review and real-account A/B checks are internal recommendations, not additional official clauses. Historical release states remain in Git history.</a:t>
             </a:r>
           </a:p>
         </p:txBody>
@@ -885,7 +885,7 @@
   </p:cSld>
   <p:clrMap bg1="lt1" tx1="dk1" bg2="lt2" tx2="dk2" accent1="accent1" accent2="accent2" accent3="accent3" accent4="accent4" accent5="accent5" accent6="accent6" hlink="hlink" folHlink="folHlink"/>
   <p:sldLayoutIdLst>
-    <p:sldLayoutId xmlns:r="http://schemas.openxmlformats.org/officeDocument/2006/relationships" id="2147483649" r:id="Rbddc671105524e17"/>
+    <p:sldLayoutId xmlns:r="http://schemas.openxmlformats.org/officeDocument/2006/relationships" id="2147483649" r:id="R1e5346351163435b"/>
   </p:sldLayoutIdLst>
   <p:txStyles>
     <p:titleStyle>
@@ -1706,7 +1706,7 @@
                 <a:ea typeface="Arial"/>
                 <a:cs typeface="Arial"/>
               </a:rPr>
-              <a:t>Roberto Villafuerte   Jorge Arguello   Daniel Andrade</a:t>
+              <a:t>Roberto Villafuerte</a:t>
             </a:r>
           </a:p>
         </p:txBody>
@@ -2639,7 +2639,7 @@
           <p:nvPr/>
         </p:nvPicPr>
         <p:blipFill>
-          <a:blip xmlns:r="http://schemas.openxmlformats.org/officeDocument/2006/relationships" xmlns:a="http://schemas.openxmlformats.org/drawingml/2006/main" r:embed="Rc30f02ea0f714602"/>
+          <a:blip xmlns:r="http://schemas.openxmlformats.org/officeDocument/2006/relationships" xmlns:a="http://schemas.openxmlformats.org/drawingml/2006/main" r:embed="R80004f4c700e48f9"/>
           <a:stretch xmlns:a="http://schemas.openxmlformats.org/drawingml/2006/main"/>
         </p:blipFill>
         <p:spPr>
@@ -3229,7 +3229,7 @@
       </p:sp>
       <p:cxnSp>
         <p:nvCxnSpPr>
-          <p:cNvPr id="54" name=""/>
+          <p:cNvPr id="76" name=""/>
           <p:cNvCxnSpPr>
             <a:stCxn xmlns:a="http://schemas.openxmlformats.org/drawingml/2006/main" id="3" idx="3"/>
             <a:endCxn xmlns:a="http://schemas.openxmlformats.org/drawingml/2006/main" id="4" idx="1"/>
@@ -3254,7 +3254,7 @@
       </p:cxnSp>
       <p:cxnSp>
         <p:nvCxnSpPr>
-          <p:cNvPr id="55" name=""/>
+          <p:cNvPr id="77" name=""/>
           <p:cNvCxnSpPr>
             <a:stCxn xmlns:a="http://schemas.openxmlformats.org/drawingml/2006/main" id="4" idx="3"/>
             <a:endCxn xmlns:a="http://schemas.openxmlformats.org/drawingml/2006/main" id="5" idx="1"/>
@@ -3279,7 +3279,7 @@
       </p:cxnSp>
       <p:cxnSp>
         <p:nvCxnSpPr>
-          <p:cNvPr id="56" name=""/>
+          <p:cNvPr id="78" name=""/>
           <p:cNvCxnSpPr>
             <a:stCxn xmlns:a="http://schemas.openxmlformats.org/drawingml/2006/main" id="5" idx="2"/>
             <a:endCxn xmlns:a="http://schemas.openxmlformats.org/drawingml/2006/main" id="6" idx="0"/>
@@ -3304,7 +3304,7 @@
       </p:cxnSp>
       <p:cxnSp>
         <p:nvCxnSpPr>
-          <p:cNvPr id="57" name=""/>
+          <p:cNvPr id="79" name=""/>
           <p:cNvCxnSpPr>
             <a:stCxn xmlns:a="http://schemas.openxmlformats.org/drawingml/2006/main" id="6" idx="1"/>
             <a:endCxn xmlns:a="http://schemas.openxmlformats.org/drawingml/2006/main" id="7" idx="3"/>
@@ -5722,7 +5722,7 @@
                 <a:latin typeface="Arial"/>
                 <a:ea typeface="Arial"/>
                 <a:cs typeface="Arial"/>
-                <a:hlinkClick xmlns:r="http://schemas.openxmlformats.org/officeDocument/2006/relationships" r:id="R0771042c96f64350"/>
+                <a:hlinkClick xmlns:r="http://schemas.openxmlformats.org/officeDocument/2006/relationships" r:id="Readfaa0db61a4f0b"/>
               </a:rPr>
               <a:t>Open prototype</a:t>
             </a:r>
@@ -5781,7 +5781,7 @@
                 <a:latin typeface="Arial"/>
                 <a:ea typeface="Arial"/>
                 <a:cs typeface="Arial"/>
-                <a:hlinkClick xmlns:r="http://schemas.openxmlformats.org/officeDocument/2006/relationships" r:id="R764b02792eb24cbf"/>
+                <a:hlinkClick xmlns:r="http://schemas.openxmlformats.org/officeDocument/2006/relationships" r:id="R8e9d645440494536"/>
               </a:rPr>
               <a:t>Code and reproduction</a:t>
             </a:r>
@@ -5833,7 +5833,7 @@
               </a:defRPr>
             </a:pPr>
             <a:r>
-              <a:rPr sz="1800" b="0">
+              <a:rPr sz="1500" b="0">
                 <a:solidFill>
                   <a:srgbClr val="536672"/>
                 </a:solidFill>
@@ -5841,7 +5841,31 @@
                 <a:ea typeface="Arial"/>
                 <a:cs typeface="Arial"/>
               </a:rPr>
-              <a:t>Restricted demo and private code. Release and judge access need approval.</a:t>
+              <a:t>Public repository, landing page and guide. Case workflow requires sign-in.</a:t>
+            </a:r>
+          </a:p>
+          <a:p xmlns:a="http://schemas.openxmlformats.org/drawingml/2006/main">
+            <a:pPr>
+              <a:buNone/>
+              <a:defRPr sz="1800" b="0">
+                <a:solidFill>
+                  <a:srgbClr val="536672"/>
+                </a:solidFill>
+                <a:latin typeface="Arial"/>
+                <a:ea typeface="Arial"/>
+                <a:cs typeface="Arial"/>
+              </a:defRPr>
+            </a:pPr>
+            <a:r>
+              <a:rPr sz="1500" b="0">
+                <a:solidFill>
+                  <a:srgbClr val="536672"/>
+                </a:solidFill>
+                <a:latin typeface="Arial"/>
+                <a:ea typeface="Arial"/>
+                <a:cs typeface="Arial"/>
+              </a:rPr>
+              <a:t>Two-account isolation has not been validated.</a:t>
             </a:r>
           </a:p>
         </p:txBody>

</xml_diff>